<commit_message>
Rebuild course artifacts (9 files)
</commit_message>
<xml_diff>
--- a/vertebrate_neural_architecture/vertebrate_neural_architecture_lecture_3.pptx
+++ b/vertebrate_neural_architecture/vertebrate_neural_architecture_lecture_3.pptx
@@ -8293,8 +8293,8 @@
         </p:blipFill>
         <p:spPr>
           <a:xfrm>
-            <a:off x="1197864" y="1737360"/>
-            <a:ext cx="9798558" cy="4983266"/>
+            <a:off x="1408176" y="1737360"/>
+            <a:ext cx="9377172" cy="4983297"/>
           </a:xfrm>
           <a:prstGeom prst="rect">
             <a:avLst/>

</xml_diff>